<commit_message>
v1.1.0: rama LLM few-shot ejecutada (Claude Sonnet 5.5) y comparada; README, docs, cuaderno 05, llm_resumen.json; presentaciones actualizadas; guiones fuera del repositorio
Co-Authored-By: Claude Fable 5.1 <noreply@anthropic.com>
Claude-Session: https://claude.ai/code/session_01WoNHoUaGaerBW2JnaGJH3V
</commit_message>
<xml_diff>
--- a/results/reports/presentacion_final/Grupo_9_Presentacion_Final.pptx
+++ b/results/reports/presentacion_final/Grupo_9_Presentacion_Final.pptx
@@ -1326,7 +1326,7 @@
             <a:r>
               <a:rPr lang="en-US" dirty="0"/>
               <a:t>[9:35–10:30] Conjunto de prueba a ciegas
-El conjunto ciego son exactamente las normas que el investigador de GENIAL codificó a ciegas: 125 con sus duplicados por URL, con las etiquetas leídas una única vez al final del cuaderno. Sobre él, la regresión logística obtiene exactitud de 0.69 y F1 macro de 0.62, con intervalo entre 0.51 y 0.71: compatible con la validación cruzada, aunque más alto, porque la muestra del investigador está dominada por normas de confianza alta y solo contiene diez normas técnicas. La SVM obtiene 0.65 de F1 macro; la diferencia no es significativa —McNemar da p de 0.13 sobre cuatro discordancias— y mantenemos la regresión logística por sus probabilidades calibradas. La rama LLM requiere una clave de API; el cuaderno la ejecuta y recalcula toda la comparación en cuanto la clave está disponible, antes del cierre del proyecto.</a:t>
+El conjunto ciego son exactamente las normas que el investigador de GENIAL codificó a ciegas: 125 con sus duplicados por URL, con las etiquetas leídas una única vez al final del cuaderno. Sobre él, la regresión logística obtiene exactitud de 0.69 y F1 macro de 0.62, con intervalo entre 0.51 y 0.71: compatible con la validación cruzada, aunque más alto, porque la muestra del investigador está dominada por normas de confianza alta y solo contiene diez normas técnicas. La SVM obtiene 0.65 de F1 macro; la diferencia no es significativa —McNemar da p de 0.13 sobre cuatro discordancias— y mantenemos la regresión logística por sus probabilidades calibradas. La rama LLM few-shot —Claude Sonnet 5.5 con quince ejemplos y tres ejecuciones— obtiene 0.64 de exactitud y 0.55 de F1 macro, con kappa 0.53: empata estadísticamente con la regresión logística, McNemar p de 0.36, y pierde en las clases pequeñas; seis normas no obtuvieron respuesta. Un modelo lineal con 673 ejemplos iguala al LLM sin coste por llamada ni envío de texto a terceros.</a:t>
             </a:r>
             <a:endParaRPr lang="en-US" dirty="0"/>
           </a:p>
@@ -1773,7 +1773,7 @@
               <a:rPr lang="en-US" dirty="0"/>
               <a:t>[13:55–14:25] Contraste con los umbrales prefijados y limitaciones
 Contrastamos cada resultado con el criterio prefijado. Superar ambas líneas base con significancia: cumplido. F1 macro mínimo de 0.60: en el borde, 0.587 en validación cruzada y 0.617 en el conjunto ciego. Excelencia de 0.70: no alcanzado. Ninguna clase bajo 0.40: incumplido por Técnico. Kappa de 0.60: no alcanzado, con 0.50 y 0.56. Enrutar menos del 30 por ciento con 85 por ciento de exactitud: no viable.
-Las limitaciones: un solo codificador por norma en la referencia, así que parte del error puede ser desacuerdo legítimo; el kappa humano-humano sigue pendiente y la plantilla para obtenerlo está generada. Texto corto y en parte redactado por el codificador. Conjunto ciego pequeño. Y la rama LLM pendiente de ejecución.</a:t>
+Las limitaciones: un solo codificador por norma en la referencia, así que parte del error puede ser desacuerdo legítimo; el kappa humano-humano sigue pendiente y la plantilla para obtenerlo está generada. Texto corto y en parte redactado por el codificador. Conjunto ciego pequeño. Y la rama LLM evaluada con un solo proveedor y un solo prompt.</a:t>
             </a:r>
             <a:endParaRPr lang="en-US" dirty="0"/>
           </a:p>
@@ -1863,7 +1863,7 @@
               <a:rPr lang="en-US" dirty="0"/>
               <a:t>[14:25–14:50] Conclusiones y trabajo futuro
 Tres conclusiones. Primera: con 813 normas y texto corto, un modelo lineal interpretable aprende la estructura del framework GENIAL y supera con significancia a toda heurística sin IA, pero no alcanza la calidad para sustituir al codificador. Segunda: su valor está en la asistencia —dos candidatas correctas en el 85 por ciento de los casos— y en el diagnóstico: sus errores señalan normas de frontera y dimensiones cuya definición conviene revisar. Tercera: umbrales prefijados, intervalos de confianza y pruebas pareadas permiten decirlo con rigor.
-Trabajo futuro: cerrar la comparación con la rama LLM, medir el techo humano con doble codificación, ampliar el texto de entrada y evaluar un esquema multi-etiqueta.</a:t>
+Trabajo futuro: usar el LLM como segunda opinión en las normas que van a revisión, medir el techo humano con doble codificación, ampliar el texto de entrada y evaluar un esquema multi-etiqueta.</a:t>
             </a:r>
             <a:endParaRPr lang="en-US" dirty="0"/>
           </a:p>
@@ -10219,13 +10219,13 @@
                       <a:r>
                         <a:rPr lang="en-US" sz="1150" dirty="0">
                           <a:solidFill>
-                            <a:srgbClr val="6E6862"/>
+                            <a:srgbClr val="1B1A19"/>
                           </a:solidFill>
                           <a:latin typeface="Calibri" pitchFamily="34" charset="0"/>
                           <a:ea typeface="Calibri" pitchFamily="34" charset="-122"/>
                           <a:cs typeface="Calibri" pitchFamily="34" charset="-120"/>
                         </a:rPr>
-                        <a:t>LLM few-shot</a:t>
+                        <a:t>LLM few-shot (Claude Sonnet 5.5, 15 ejemplos)</a:t>
                       </a:r>
                       <a:endParaRPr lang="en-US" sz="1150" dirty="0">
                         <a:latin typeface="Calibri" charset="0"/>
@@ -10273,7 +10273,7 @@
                     </a:lnB>
                   </a:tcPr>
                 </a:tc>
-                <a:tc gridSpan="4">
+                <a:tc>
                   <a:txBody>
                     <a:bodyPr/>
                     <a:lstStyle/>
@@ -10282,15 +10282,15 @@
                         <a:buNone/>
                       </a:pPr>
                       <a:r>
-                        <a:rPr lang="en-US" sz="1150" i="1" dirty="0">
+                        <a:rPr lang="en-US" sz="1150" dirty="0">
                           <a:solidFill>
-                            <a:srgbClr val="6E6862"/>
+                            <a:srgbClr val="1B1A19"/>
                           </a:solidFill>
                           <a:latin typeface="Calibri" pitchFamily="34" charset="0"/>
                           <a:ea typeface="Calibri" pitchFamily="34" charset="-122"/>
                           <a:cs typeface="Calibri" pitchFamily="34" charset="-120"/>
                         </a:rPr>
-                        <a:t>pendiente: requiere clave de API (ejecución local)</a:t>
+                        <a:t>0.640 [0.553, 0.719]</a:t>
                       </a:r>
                       <a:endParaRPr lang="en-US" sz="1150" dirty="0">
                         <a:latin typeface="Calibri" charset="0"/>
@@ -10338,14 +10338,200 @@
                     </a:lnB>
                   </a:tcPr>
                 </a:tc>
-                <a:tc hMerge="1">
-                  <a:tcPr/>
+                <a:tc>
+                  <a:txBody>
+                    <a:bodyPr/>
+                    <a:lstStyle/>
+                    <a:p>
+                      <a:pPr indent="0" marL="0">
+                        <a:buNone/>
+                      </a:pPr>
+                      <a:r>
+                        <a:rPr lang="en-US" sz="1150" dirty="0">
+                          <a:solidFill>
+                            <a:srgbClr val="1B1A19"/>
+                          </a:solidFill>
+                          <a:latin typeface="Calibri" pitchFamily="34" charset="0"/>
+                          <a:ea typeface="Calibri" pitchFamily="34" charset="-122"/>
+                          <a:cs typeface="Calibri" pitchFamily="34" charset="-120"/>
+                        </a:rPr>
+                        <a:t>0.554 [0.447, 0.648]</a:t>
+                      </a:r>
+                      <a:endParaRPr lang="en-US" sz="1150" dirty="0">
+                        <a:latin typeface="Calibri" charset="0"/>
+                        <a:ea typeface="Calibri" charset="0"/>
+                        <a:cs typeface="Calibri" charset="0"/>
+                      </a:endParaRPr>
+                    </a:p>
+                  </a:txBody>
+                  <a:tcPr marL="64008" marR="64008" marT="64008" marB="64008" anchor="ctr">
+                    <a:lnL w="6350" cap="flat" cmpd="sng" algn="ctr">
+                      <a:solidFill>
+                        <a:srgbClr val="DDD6D0"/>
+                      </a:solidFill>
+                      <a:prstDash val="solid"/>
+                      <a:round/>
+                      <a:headEnd type="none" w="med" len="med"/>
+                      <a:tailEnd type="none" w="med" len="med"/>
+                    </a:lnL>
+                    <a:lnR w="6350" cap="flat" cmpd="sng" algn="ctr">
+                      <a:solidFill>
+                        <a:srgbClr val="DDD6D0"/>
+                      </a:solidFill>
+                      <a:prstDash val="solid"/>
+                      <a:round/>
+                      <a:headEnd type="none" w="med" len="med"/>
+                      <a:tailEnd type="none" w="med" len="med"/>
+                    </a:lnR>
+                    <a:lnT w="6350" cap="flat" cmpd="sng" algn="ctr">
+                      <a:solidFill>
+                        <a:srgbClr val="DDD6D0"/>
+                      </a:solidFill>
+                      <a:prstDash val="solid"/>
+                      <a:round/>
+                      <a:headEnd type="none" w="med" len="med"/>
+                      <a:tailEnd type="none" w="med" len="med"/>
+                    </a:lnT>
+                    <a:lnB w="6350" cap="flat" cmpd="sng" algn="ctr">
+                      <a:solidFill>
+                        <a:srgbClr val="DDD6D0"/>
+                      </a:solidFill>
+                      <a:prstDash val="solid"/>
+                      <a:round/>
+                      <a:headEnd type="none" w="med" len="med"/>
+                      <a:tailEnd type="none" w="med" len="med"/>
+                    </a:lnB>
+                  </a:tcPr>
                 </a:tc>
-                <a:tc hMerge="1">
-                  <a:tcPr/>
+                <a:tc>
+                  <a:txBody>
+                    <a:bodyPr/>
+                    <a:lstStyle/>
+                    <a:p>
+                      <a:pPr indent="0" marL="0">
+                        <a:buNone/>
+                      </a:pPr>
+                      <a:r>
+                        <a:rPr lang="en-US" sz="1150" dirty="0">
+                          <a:solidFill>
+                            <a:srgbClr val="1B1A19"/>
+                          </a:solidFill>
+                          <a:latin typeface="Calibri" pitchFamily="34" charset="0"/>
+                          <a:ea typeface="Calibri" pitchFamily="34" charset="-122"/>
+                          <a:cs typeface="Calibri" pitchFamily="34" charset="-120"/>
+                        </a:rPr>
+                        <a:t>0.824</a:t>
+                      </a:r>
+                      <a:endParaRPr lang="en-US" sz="1150" dirty="0">
+                        <a:latin typeface="Calibri" charset="0"/>
+                        <a:ea typeface="Calibri" charset="0"/>
+                        <a:cs typeface="Calibri" charset="0"/>
+                      </a:endParaRPr>
+                    </a:p>
+                  </a:txBody>
+                  <a:tcPr marL="64008" marR="64008" marT="64008" marB="64008" anchor="ctr">
+                    <a:lnL w="6350" cap="flat" cmpd="sng" algn="ctr">
+                      <a:solidFill>
+                        <a:srgbClr val="DDD6D0"/>
+                      </a:solidFill>
+                      <a:prstDash val="solid"/>
+                      <a:round/>
+                      <a:headEnd type="none" w="med" len="med"/>
+                      <a:tailEnd type="none" w="med" len="med"/>
+                    </a:lnL>
+                    <a:lnR w="6350" cap="flat" cmpd="sng" algn="ctr">
+                      <a:solidFill>
+                        <a:srgbClr val="DDD6D0"/>
+                      </a:solidFill>
+                      <a:prstDash val="solid"/>
+                      <a:round/>
+                      <a:headEnd type="none" w="med" len="med"/>
+                      <a:tailEnd type="none" w="med" len="med"/>
+                    </a:lnR>
+                    <a:lnT w="6350" cap="flat" cmpd="sng" algn="ctr">
+                      <a:solidFill>
+                        <a:srgbClr val="DDD6D0"/>
+                      </a:solidFill>
+                      <a:prstDash val="solid"/>
+                      <a:round/>
+                      <a:headEnd type="none" w="med" len="med"/>
+                      <a:tailEnd type="none" w="med" len="med"/>
+                    </a:lnT>
+                    <a:lnB w="6350" cap="flat" cmpd="sng" algn="ctr">
+                      <a:solidFill>
+                        <a:srgbClr val="DDD6D0"/>
+                      </a:solidFill>
+                      <a:prstDash val="solid"/>
+                      <a:round/>
+                      <a:headEnd type="none" w="med" len="med"/>
+                      <a:tailEnd type="none" w="med" len="med"/>
+                    </a:lnB>
+                  </a:tcPr>
                 </a:tc>
-                <a:tc hMerge="1">
-                  <a:tcPr/>
+                <a:tc>
+                  <a:txBody>
+                    <a:bodyPr/>
+                    <a:lstStyle/>
+                    <a:p>
+                      <a:pPr indent="0" marL="0">
+                        <a:buNone/>
+                      </a:pPr>
+                      <a:r>
+                        <a:rPr lang="en-US" sz="1150" dirty="0">
+                          <a:solidFill>
+                            <a:srgbClr val="1B1A19"/>
+                          </a:solidFill>
+                          <a:latin typeface="Calibri" pitchFamily="34" charset="0"/>
+                          <a:ea typeface="Calibri" pitchFamily="34" charset="-122"/>
+                          <a:cs typeface="Calibri" pitchFamily="34" charset="-120"/>
+                        </a:rPr>
+                        <a:t>0.53</a:t>
+                      </a:r>
+                      <a:endParaRPr lang="en-US" sz="1150" dirty="0">
+                        <a:latin typeface="Calibri" charset="0"/>
+                        <a:ea typeface="Calibri" charset="0"/>
+                        <a:cs typeface="Calibri" charset="0"/>
+                      </a:endParaRPr>
+                    </a:p>
+                  </a:txBody>
+                  <a:tcPr marL="64008" marR="64008" marT="64008" marB="64008" anchor="ctr">
+                    <a:lnL w="6350" cap="flat" cmpd="sng" algn="ctr">
+                      <a:solidFill>
+                        <a:srgbClr val="DDD6D0"/>
+                      </a:solidFill>
+                      <a:prstDash val="solid"/>
+                      <a:round/>
+                      <a:headEnd type="none" w="med" len="med"/>
+                      <a:tailEnd type="none" w="med" len="med"/>
+                    </a:lnL>
+                    <a:lnR w="6350" cap="flat" cmpd="sng" algn="ctr">
+                      <a:solidFill>
+                        <a:srgbClr val="DDD6D0"/>
+                      </a:solidFill>
+                      <a:prstDash val="solid"/>
+                      <a:round/>
+                      <a:headEnd type="none" w="med" len="med"/>
+                      <a:tailEnd type="none" w="med" len="med"/>
+                    </a:lnR>
+                    <a:lnT w="6350" cap="flat" cmpd="sng" algn="ctr">
+                      <a:solidFill>
+                        <a:srgbClr val="DDD6D0"/>
+                      </a:solidFill>
+                      <a:prstDash val="solid"/>
+                      <a:round/>
+                      <a:headEnd type="none" w="med" len="med"/>
+                      <a:tailEnd type="none" w="med" len="med"/>
+                    </a:lnT>
+                    <a:lnB w="6350" cap="flat" cmpd="sng" algn="ctr">
+                      <a:solidFill>
+                        <a:srgbClr val="DDD6D0"/>
+                      </a:solidFill>
+                      <a:prstDash val="solid"/>
+                      <a:round/>
+                      <a:headEnd type="none" w="med" len="med"/>
+                      <a:tailEnd type="none" w="med" len="med"/>
+                    </a:lnB>
+                  </a:tcPr>
                 </a:tc>
               </a:tr>
             </a:tbl>
@@ -11196,6 +11382,268 @@
                           <a:ea typeface="Calibri" pitchFamily="34" charset="-122"/>
                           <a:cs typeface="Calibri" pitchFamily="34" charset="-120"/>
                         </a:rPr>
+                        <a:t>LLM few-shot vs RL</a:t>
+                      </a:r>
+                      <a:endParaRPr lang="en-US" sz="1100" dirty="0">
+                        <a:latin typeface="Calibri" charset="0"/>
+                        <a:ea typeface="Calibri" charset="0"/>
+                        <a:cs typeface="Calibri" charset="0"/>
+                      </a:endParaRPr>
+                    </a:p>
+                  </a:txBody>
+                  <a:tcPr marL="54864" marR="54864" marT="54864" marB="54864" anchor="ctr">
+                    <a:lnL w="6350" cap="flat" cmpd="sng" algn="ctr">
+                      <a:solidFill>
+                        <a:srgbClr val="DDD6D0"/>
+                      </a:solidFill>
+                      <a:prstDash val="solid"/>
+                      <a:round/>
+                      <a:headEnd type="none" w="med" len="med"/>
+                      <a:tailEnd type="none" w="med" len="med"/>
+                    </a:lnL>
+                    <a:lnR w="6350" cap="flat" cmpd="sng" algn="ctr">
+                      <a:solidFill>
+                        <a:srgbClr val="DDD6D0"/>
+                      </a:solidFill>
+                      <a:prstDash val="solid"/>
+                      <a:round/>
+                      <a:headEnd type="none" w="med" len="med"/>
+                      <a:tailEnd type="none" w="med" len="med"/>
+                    </a:lnR>
+                    <a:lnT w="6350" cap="flat" cmpd="sng" algn="ctr">
+                      <a:solidFill>
+                        <a:srgbClr val="DDD6D0"/>
+                      </a:solidFill>
+                      <a:prstDash val="solid"/>
+                      <a:round/>
+                      <a:headEnd type="none" w="med" len="med"/>
+                      <a:tailEnd type="none" w="med" len="med"/>
+                    </a:lnT>
+                    <a:lnB w="6350" cap="flat" cmpd="sng" algn="ctr">
+                      <a:solidFill>
+                        <a:srgbClr val="DDD6D0"/>
+                      </a:solidFill>
+                      <a:prstDash val="solid"/>
+                      <a:round/>
+                      <a:headEnd type="none" w="med" len="med"/>
+                      <a:tailEnd type="none" w="med" len="med"/>
+                    </a:lnB>
+                  </a:tcPr>
+                </a:tc>
+                <a:tc>
+                  <a:txBody>
+                    <a:bodyPr/>
+                    <a:lstStyle/>
+                    <a:p>
+                      <a:pPr indent="0" marL="0">
+                        <a:buNone/>
+                      </a:pPr>
+                      <a:r>
+                        <a:rPr lang="en-US" sz="1100" dirty="0">
+                          <a:solidFill>
+                            <a:srgbClr val="1B1A19"/>
+                          </a:solidFill>
+                          <a:latin typeface="Calibri" pitchFamily="34" charset="0"/>
+                          <a:ea typeface="Calibri" pitchFamily="34" charset="-122"/>
+                          <a:cs typeface="Calibri" pitchFamily="34" charset="-120"/>
+                        </a:rPr>
+                        <a:t>12</a:t>
+                      </a:r>
+                      <a:endParaRPr lang="en-US" sz="1100" dirty="0">
+                        <a:latin typeface="Calibri" charset="0"/>
+                        <a:ea typeface="Calibri" charset="0"/>
+                        <a:cs typeface="Calibri" charset="0"/>
+                      </a:endParaRPr>
+                    </a:p>
+                  </a:txBody>
+                  <a:tcPr marL="54864" marR="54864" marT="54864" marB="54864" anchor="ctr">
+                    <a:lnL w="6350" cap="flat" cmpd="sng" algn="ctr">
+                      <a:solidFill>
+                        <a:srgbClr val="DDD6D0"/>
+                      </a:solidFill>
+                      <a:prstDash val="solid"/>
+                      <a:round/>
+                      <a:headEnd type="none" w="med" len="med"/>
+                      <a:tailEnd type="none" w="med" len="med"/>
+                    </a:lnL>
+                    <a:lnR w="6350" cap="flat" cmpd="sng" algn="ctr">
+                      <a:solidFill>
+                        <a:srgbClr val="DDD6D0"/>
+                      </a:solidFill>
+                      <a:prstDash val="solid"/>
+                      <a:round/>
+                      <a:headEnd type="none" w="med" len="med"/>
+                      <a:tailEnd type="none" w="med" len="med"/>
+                    </a:lnR>
+                    <a:lnT w="6350" cap="flat" cmpd="sng" algn="ctr">
+                      <a:solidFill>
+                        <a:srgbClr val="DDD6D0"/>
+                      </a:solidFill>
+                      <a:prstDash val="solid"/>
+                      <a:round/>
+                      <a:headEnd type="none" w="med" len="med"/>
+                      <a:tailEnd type="none" w="med" len="med"/>
+                    </a:lnT>
+                    <a:lnB w="6350" cap="flat" cmpd="sng" algn="ctr">
+                      <a:solidFill>
+                        <a:srgbClr val="DDD6D0"/>
+                      </a:solidFill>
+                      <a:prstDash val="solid"/>
+                      <a:round/>
+                      <a:headEnd type="none" w="med" len="med"/>
+                      <a:tailEnd type="none" w="med" len="med"/>
+                    </a:lnB>
+                  </a:tcPr>
+                </a:tc>
+                <a:tc>
+                  <a:txBody>
+                    <a:bodyPr/>
+                    <a:lstStyle/>
+                    <a:p>
+                      <a:pPr indent="0" marL="0">
+                        <a:buNone/>
+                      </a:pPr>
+                      <a:r>
+                        <a:rPr lang="en-US" sz="1100" dirty="0">
+                          <a:solidFill>
+                            <a:srgbClr val="1B1A19"/>
+                          </a:solidFill>
+                          <a:latin typeface="Calibri" pitchFamily="34" charset="0"/>
+                          <a:ea typeface="Calibri" pitchFamily="34" charset="-122"/>
+                          <a:cs typeface="Calibri" pitchFamily="34" charset="-120"/>
+                        </a:rPr>
+                        <a:t>18</a:t>
+                      </a:r>
+                      <a:endParaRPr lang="en-US" sz="1100" dirty="0">
+                        <a:latin typeface="Calibri" charset="0"/>
+                        <a:ea typeface="Calibri" charset="0"/>
+                        <a:cs typeface="Calibri" charset="0"/>
+                      </a:endParaRPr>
+                    </a:p>
+                  </a:txBody>
+                  <a:tcPr marL="54864" marR="54864" marT="54864" marB="54864" anchor="ctr">
+                    <a:lnL w="6350" cap="flat" cmpd="sng" algn="ctr">
+                      <a:solidFill>
+                        <a:srgbClr val="DDD6D0"/>
+                      </a:solidFill>
+                      <a:prstDash val="solid"/>
+                      <a:round/>
+                      <a:headEnd type="none" w="med" len="med"/>
+                      <a:tailEnd type="none" w="med" len="med"/>
+                    </a:lnL>
+                    <a:lnR w="6350" cap="flat" cmpd="sng" algn="ctr">
+                      <a:solidFill>
+                        <a:srgbClr val="DDD6D0"/>
+                      </a:solidFill>
+                      <a:prstDash val="solid"/>
+                      <a:round/>
+                      <a:headEnd type="none" w="med" len="med"/>
+                      <a:tailEnd type="none" w="med" len="med"/>
+                    </a:lnR>
+                    <a:lnT w="6350" cap="flat" cmpd="sng" algn="ctr">
+                      <a:solidFill>
+                        <a:srgbClr val="DDD6D0"/>
+                      </a:solidFill>
+                      <a:prstDash val="solid"/>
+                      <a:round/>
+                      <a:headEnd type="none" w="med" len="med"/>
+                      <a:tailEnd type="none" w="med" len="med"/>
+                    </a:lnT>
+                    <a:lnB w="6350" cap="flat" cmpd="sng" algn="ctr">
+                      <a:solidFill>
+                        <a:srgbClr val="DDD6D0"/>
+                      </a:solidFill>
+                      <a:prstDash val="solid"/>
+                      <a:round/>
+                      <a:headEnd type="none" w="med" len="med"/>
+                      <a:tailEnd type="none" w="med" len="med"/>
+                    </a:lnB>
+                  </a:tcPr>
+                </a:tc>
+                <a:tc>
+                  <a:txBody>
+                    <a:bodyPr/>
+                    <a:lstStyle/>
+                    <a:p>
+                      <a:pPr indent="0" marL="0">
+                        <a:buNone/>
+                      </a:pPr>
+                      <a:r>
+                        <a:rPr lang="en-US" sz="1100" b="1" dirty="0">
+                          <a:solidFill>
+                            <a:srgbClr val="B8860B"/>
+                          </a:solidFill>
+                          <a:latin typeface="Calibri" pitchFamily="34" charset="0"/>
+                          <a:ea typeface="Calibri" pitchFamily="34" charset="-122"/>
+                          <a:cs typeface="Calibri" pitchFamily="34" charset="-120"/>
+                        </a:rPr>
+                        <a:t>0.36 (n.s.)</a:t>
+                      </a:r>
+                      <a:endParaRPr lang="en-US" sz="1100" dirty="0">
+                        <a:latin typeface="Calibri" charset="0"/>
+                        <a:ea typeface="Calibri" charset="0"/>
+                        <a:cs typeface="Calibri" charset="0"/>
+                      </a:endParaRPr>
+                    </a:p>
+                  </a:txBody>
+                  <a:tcPr marL="54864" marR="54864" marT="54864" marB="54864" anchor="ctr">
+                    <a:lnL w="6350" cap="flat" cmpd="sng" algn="ctr">
+                      <a:solidFill>
+                        <a:srgbClr val="DDD6D0"/>
+                      </a:solidFill>
+                      <a:prstDash val="solid"/>
+                      <a:round/>
+                      <a:headEnd type="none" w="med" len="med"/>
+                      <a:tailEnd type="none" w="med" len="med"/>
+                    </a:lnL>
+                    <a:lnR w="6350" cap="flat" cmpd="sng" algn="ctr">
+                      <a:solidFill>
+                        <a:srgbClr val="DDD6D0"/>
+                      </a:solidFill>
+                      <a:prstDash val="solid"/>
+                      <a:round/>
+                      <a:headEnd type="none" w="med" len="med"/>
+                      <a:tailEnd type="none" w="med" len="med"/>
+                    </a:lnR>
+                    <a:lnT w="6350" cap="flat" cmpd="sng" algn="ctr">
+                      <a:solidFill>
+                        <a:srgbClr val="DDD6D0"/>
+                      </a:solidFill>
+                      <a:prstDash val="solid"/>
+                      <a:round/>
+                      <a:headEnd type="none" w="med" len="med"/>
+                      <a:tailEnd type="none" w="med" len="med"/>
+                    </a:lnT>
+                    <a:lnB w="6350" cap="flat" cmpd="sng" algn="ctr">
+                      <a:solidFill>
+                        <a:srgbClr val="DDD6D0"/>
+                      </a:solidFill>
+                      <a:prstDash val="solid"/>
+                      <a:round/>
+                      <a:headEnd type="none" w="med" len="med"/>
+                      <a:tailEnd type="none" w="med" len="med"/>
+                    </a:lnB>
+                  </a:tcPr>
+                </a:tc>
+              </a:tr>
+              <a:tr h="365760">
+                <a:tc>
+                  <a:txBody>
+                    <a:bodyPr/>
+                    <a:lstStyle/>
+                    <a:p>
+                      <a:pPr indent="0" marL="0">
+                        <a:buNone/>
+                      </a:pPr>
+                      <a:r>
+                        <a:rPr lang="en-US" sz="1100" dirty="0">
+                          <a:solidFill>
+                            <a:srgbClr val="1B1A19"/>
+                          </a:solidFill>
+                          <a:latin typeface="Calibri" pitchFamily="34" charset="0"/>
+                          <a:ea typeface="Calibri" pitchFamily="34" charset="-122"/>
+                          <a:cs typeface="Calibri" pitchFamily="34" charset="-120"/>
+                        </a:rPr>
                         <a:t>RL vs SVM lineal</a:t>
                       </a:r>
                       <a:endParaRPr lang="en-US" sz="1100" dirty="0">
@@ -17123,7 +17571,7 @@
                 <a:ea typeface="Calibri" pitchFamily="34" charset="-122"/>
                 <a:cs typeface="Calibri" pitchFamily="34" charset="-120"/>
               </a:rPr>
-              <a:t>Rama LLM few-shot pendiente de ejecución (clave de API): la comparación TF-IDF vs LLM sigue abierta.</a:t>
+              <a:t>Rama LLM evaluada con un solo proveedor y un solo prompt (Claude Sonnet 5.5): 6 normas sin respuesta; empate estadístico con la RL.</a:t>
             </a:r>
             <a:endParaRPr lang="en-US" sz="1150" dirty="0"/>
           </a:p>
@@ -17967,7 +18415,7 @@
                 <a:ea typeface="Calibri" pitchFamily="34" charset="-122"/>
                 <a:cs typeface="Calibri" pitchFamily="34" charset="-120"/>
               </a:rPr>
-              <a:t>Cerrar la comparación · </a:t>
+              <a:t>LLM como segunda opinión · </a:t>
             </a:r>
             <a:pPr indent="0" marL="0">
               <a:buNone/>
@@ -17981,7 +18429,7 @@
                 <a:ea typeface="Calibri" pitchFamily="34" charset="-122"/>
                 <a:cs typeface="Calibri" pitchFamily="34" charset="-120"/>
               </a:rPr>
-              <a:t>ejecutar la rama LLM few-shot (3 pasadas, T = 0) y recalcular McNemar y κ</a:t>
+              <a:t>usar el LLM solo en las normas enviadas a revisión humana y medir si acelera al codificador</a:t>
             </a:r>
             <a:endParaRPr lang="en-US" sz="1200" dirty="0"/>
           </a:p>

</xml_diff>